<commit_message>
added links in lecture slides
</commit_message>
<xml_diff>
--- a/docs/qmd/Day01/files/day1-L4_Documentation.pptx
+++ b/docs/qmd/Day01/files/day1-L4_Documentation.pptx
@@ -8723,7 +8723,15 @@
                   <a:schemeClr val="dk1"/>
                 </a:solidFill>
               </a:rPr>
-              <a:t>Descritpion/summary of project</a:t>
+              <a:t>Description</a:t>
+            </a:r>
+            <a:r>
+              <a:rPr lang="en">
+                <a:solidFill>
+                  <a:schemeClr val="dk1"/>
+                </a:solidFill>
+              </a:rPr>
+              <a:t>/summary of project</a:t>
             </a:r>
             <a:endParaRPr>
               <a:solidFill>
@@ -9742,18 +9750,33 @@
                   <a:schemeClr val="dk1"/>
                 </a:solidFill>
               </a:rPr>
-              <a:t>Find the links on the webpage </a:t>
+              <a:t>Find the links on the webpage: </a:t>
+            </a:r>
+            <a:r>
+              <a:rPr lang="en" u="sng">
+                <a:solidFill>
+                  <a:schemeClr val="hlink"/>
+                </a:solidFill>
+                <a:hlinkClick r:id="rId3"/>
+              </a:rPr>
+              <a:t>Activity</a:t>
+            </a:r>
+            <a:r>
+              <a:rPr lang="en" u="sng">
+                <a:solidFill>
+                  <a:schemeClr val="hlink"/>
+                </a:solidFill>
+                <a:hlinkClick r:id="rId4"/>
+              </a:rPr>
+              <a:t> - explore data documentation</a:t>
             </a:r>
             <a:r>
               <a:rPr lang="en">
                 <a:solidFill>
                   <a:schemeClr val="dk1"/>
                 </a:solidFill>
-                <a:highlight>
-                  <a:srgbClr val="FFFF00"/>
-                </a:highlight>
               </a:rPr>
-              <a:t>[include link when read]</a:t>
+              <a:t> </a:t>
             </a:r>
             <a:endParaRPr>
               <a:solidFill>
@@ -10011,18 +10034,16 @@
                   <a:schemeClr val="dk1"/>
                 </a:solidFill>
               </a:rPr>
-              <a:t>- Download the README file template </a:t>
-            </a:r>
-            <a:r>
-              <a:rPr lang="en" sz="1500">
+              <a:t>- Download the </a:t>
+            </a:r>
+            <a:r>
+              <a:rPr lang="en" sz="1500" u="sng">
                 <a:solidFill>
-                  <a:schemeClr val="dk1"/>
+                  <a:schemeClr val="hlink"/>
                 </a:solidFill>
-                <a:highlight>
-                  <a:srgbClr val="FFFF00"/>
-                </a:highlight>
+                <a:hlinkClick r:id="rId3"/>
               </a:rPr>
-              <a:t>[include link to website when ready]</a:t>
+              <a:t>README file template</a:t>
             </a:r>
             <a:endParaRPr sz="1500">
               <a:solidFill>

</xml_diff>